<commit_message>
Fix layout issues in PDF and PPTX outputs
PDF: fix cover title (remove orphaned comma before L.P.), fix page 5
distributions three-column overflow (676pt → 504pt), fix page 7 portfolio
composition two-column overflow (626pt → 500pt), fix appendix section
header indices and add SPAN for clean full-width headers.

PPTX: widen Fund Health sidebar items on slide 2, fix deal table column
proportions on slide 6, enlarge Market Context box on slide 8, increase
appendix row height on slide 9.

Co-Authored-By: Claude Sonnet 4.6 <noreply@anthropic.com>
</commit_message>
<xml_diff>
--- a/outputs/Cana_Capital_Fund_I_April_2026_Investor_Deck.pptx
+++ b/outputs/Cana_Capital_Fund_I_April_2026_Investor_Deck.pptx
@@ -2572,12 +2572,12 @@
         </p:nvSpPr>
         <p:spPr>
           <a:xfrm>
-            <a:off x="9235440" y="2468880"/>
-            <a:ext cx="2743200" cy="2743200"/>
+            <a:off x="9144000" y="2468880"/>
+            <a:ext cx="2880360" cy="2926080"/>
           </a:xfrm>
           <a:prstGeom prst="roundRect">
             <a:avLst>
-              <a:gd name="adj" fmla="val 1667"/>
+              <a:gd name="adj" fmla="val 1587"/>
             </a:avLst>
           </a:prstGeom>
           <a:solidFill>
@@ -2594,8 +2594,8 @@
         </p:nvSpPr>
         <p:spPr>
           <a:xfrm>
-            <a:off x="9235440" y="2578608"/>
-            <a:ext cx="2743200" cy="320040"/>
+            <a:off x="9144000" y="2578608"/>
+            <a:ext cx="2880360" cy="347472"/>
           </a:xfrm>
           <a:prstGeom prst="rect">
             <a:avLst/>
@@ -2611,7 +2611,7 @@
               <a:buNone/>
             </a:pPr>
             <a:r>
-              <a:rPr lang="en-US" sz="1100" b="1" dirty="0">
+              <a:rPr lang="en-US" sz="1200" b="1" dirty="0">
                 <a:solidFill>
                   <a:srgbClr val="FFFFFF"/>
                 </a:solidFill>
@@ -2621,7 +2621,7 @@
               </a:rPr>
               <a:t>Fund Health</a:t>
             </a:r>
-            <a:endParaRPr lang="en-US" sz="1100" dirty="0"/>
+            <a:endParaRPr lang="en-US" sz="1200" dirty="0"/>
           </a:p>
         </p:txBody>
       </p:sp>
@@ -2633,8 +2633,8 @@
         </p:nvSpPr>
         <p:spPr>
           <a:xfrm>
-            <a:off x="9235440" y="2898648"/>
-            <a:ext cx="2743200" cy="13716"/>
+            <a:off x="9144000" y="2926080"/>
+            <a:ext cx="2880360" cy="13716"/>
           </a:xfrm>
           <a:prstGeom prst="rect">
             <a:avLst/>
@@ -2653,8 +2653,8 @@
         </p:nvSpPr>
         <p:spPr>
           <a:xfrm>
-            <a:off x="9372600" y="2999232"/>
-            <a:ext cx="2468880" cy="365760"/>
+            <a:off x="9253728" y="3044952"/>
+            <a:ext cx="2651760" cy="402336"/>
           </a:xfrm>
           <a:prstGeom prst="rect">
             <a:avLst/>
@@ -2670,7 +2670,7 @@
               <a:buNone/>
             </a:pPr>
             <a:r>
-              <a:rPr lang="en-US" sz="950" dirty="0">
+              <a:rPr lang="en-US" sz="1050" dirty="0">
                 <a:solidFill>
                   <a:srgbClr val="1A6B3A"/>
                 </a:solidFill>
@@ -2680,7 +2680,7 @@
               </a:rPr>
               <a:t>✓ Preferred Return: CURRENT</a:t>
             </a:r>
-            <a:endParaRPr lang="en-US" sz="950" dirty="0"/>
+            <a:endParaRPr lang="en-US" sz="1050" dirty="0"/>
           </a:p>
         </p:txBody>
       </p:sp>
@@ -2692,8 +2692,8 @@
         </p:nvSpPr>
         <p:spPr>
           <a:xfrm>
-            <a:off x="9372600" y="3438144"/>
-            <a:ext cx="2468880" cy="365760"/>
+            <a:off x="9253728" y="3520440"/>
+            <a:ext cx="2651760" cy="402336"/>
           </a:xfrm>
           <a:prstGeom prst="rect">
             <a:avLst/>
@@ -2709,7 +2709,7 @@
               <a:buNone/>
             </a:pPr>
             <a:r>
-              <a:rPr lang="en-US" sz="950" dirty="0">
+              <a:rPr lang="en-US" sz="1050" dirty="0">
                 <a:solidFill>
                   <a:srgbClr val="1A6B3A"/>
                 </a:solidFill>
@@ -2719,7 +2719,7 @@
               </a:rPr>
               <a:t>✓ Portfolio: 100% Performing</a:t>
             </a:r>
-            <a:endParaRPr lang="en-US" sz="950" dirty="0"/>
+            <a:endParaRPr lang="en-US" sz="1050" dirty="0"/>
           </a:p>
         </p:txBody>
       </p:sp>
@@ -2731,8 +2731,8 @@
         </p:nvSpPr>
         <p:spPr>
           <a:xfrm>
-            <a:off x="9372600" y="3877056"/>
-            <a:ext cx="2468880" cy="365760"/>
+            <a:off x="9253728" y="3995928"/>
+            <a:ext cx="2651760" cy="402336"/>
           </a:xfrm>
           <a:prstGeom prst="rect">
             <a:avLst/>
@@ -2748,7 +2748,7 @@
               <a:buNone/>
             </a:pPr>
             <a:r>
-              <a:rPr lang="en-US" sz="950" dirty="0">
+              <a:rPr lang="en-US" sz="1050" dirty="0">
                 <a:solidFill>
                   <a:srgbClr val="1A6B3A"/>
                 </a:solidFill>
@@ -2758,7 +2758,7 @@
               </a:rPr>
               <a:t>✓ Capital: 75% Deployed</a:t>
             </a:r>
-            <a:endParaRPr lang="en-US" sz="950" dirty="0"/>
+            <a:endParaRPr lang="en-US" sz="1050" dirty="0"/>
           </a:p>
         </p:txBody>
       </p:sp>
@@ -2770,8 +2770,8 @@
         </p:nvSpPr>
         <p:spPr>
           <a:xfrm>
-            <a:off x="9372600" y="4315968"/>
-            <a:ext cx="2468880" cy="365760"/>
+            <a:off x="9253728" y="4471416"/>
+            <a:ext cx="2651760" cy="402336"/>
           </a:xfrm>
           <a:prstGeom prst="rect">
             <a:avLst/>
@@ -2787,7 +2787,7 @@
               <a:buNone/>
             </a:pPr>
             <a:r>
-              <a:rPr lang="en-US" sz="950" dirty="0">
+              <a:rPr lang="en-US" sz="1050" dirty="0">
                 <a:solidFill>
                   <a:srgbClr val="FFFFFF"/>
                 </a:solidFill>
@@ -2797,7 +2797,7 @@
               </a:rPr>
               <a:t>Net IRR: 9.1%</a:t>
             </a:r>
-            <a:endParaRPr lang="en-US" sz="950" dirty="0"/>
+            <a:endParaRPr lang="en-US" sz="1050" dirty="0"/>
           </a:p>
         </p:txBody>
       </p:sp>
@@ -2809,8 +2809,8 @@
         </p:nvSpPr>
         <p:spPr>
           <a:xfrm>
-            <a:off x="9372600" y="4754880"/>
-            <a:ext cx="2468880" cy="365760"/>
+            <a:off x="9253728" y="4946904"/>
+            <a:ext cx="2651760" cy="402336"/>
           </a:xfrm>
           <a:prstGeom prst="rect">
             <a:avLst/>
@@ -2826,7 +2826,7 @@
               <a:buNone/>
             </a:pPr>
             <a:r>
-              <a:rPr lang="en-US" sz="950" dirty="0">
+              <a:rPr lang="en-US" sz="1050" dirty="0">
                 <a:solidFill>
                   <a:srgbClr val="C9A84C"/>
                 </a:solidFill>
@@ -2836,7 +2836,7 @@
               </a:rPr>
               <a:t>MOIC: 1.08x</a:t>
             </a:r>
-            <a:endParaRPr lang="en-US" sz="950" dirty="0"/>
+            <a:endParaRPr lang="en-US" sz="1050" dirty="0"/>
           </a:p>
         </p:txBody>
       </p:sp>
@@ -11760,15 +11760,15 @@
             <a:tbl>
               <a:tblPr/>
               <a:tblGrid>
-                <a:gridCol w="2286000"/>
-                <a:gridCol w="1371600"/>
+                <a:gridCol w="2926080"/>
+                <a:gridCol w="1737360"/>
+                <a:gridCol w="1280160"/>
                 <a:gridCol w="914400"/>
-                <a:gridCol w="685800"/>
-                <a:gridCol w="1143000"/>
-                <a:gridCol w="685800"/>
-                <a:gridCol w="1371600"/>
+                <a:gridCol w="1463040"/>
+                <a:gridCol w="822960"/>
+                <a:gridCol w="1645920"/>
               </a:tblGrid>
-              <a:tr h="365760">
+              <a:tr h="402336">
                 <a:tc>
                   <a:txBody>
                     <a:bodyPr/>
@@ -12246,7 +12246,7 @@
                   </a:tcPr>
                 </a:tc>
               </a:tr>
-              <a:tr h="365760">
+              <a:tr h="402336">
                 <a:tc>
                   <a:txBody>
                     <a:bodyPr/>
@@ -12724,7 +12724,7 @@
                   </a:tcPr>
                 </a:tc>
               </a:tr>
-              <a:tr h="365760">
+              <a:tr h="402336">
                 <a:tc>
                   <a:txBody>
                     <a:bodyPr/>
@@ -17739,12 +17739,12 @@
         </p:nvSpPr>
         <p:spPr>
           <a:xfrm>
-            <a:off x="914400" y="4937760"/>
-            <a:ext cx="10332720" cy="1280160"/>
+            <a:off x="731520" y="4663440"/>
+            <a:ext cx="10789920" cy="1691640"/>
           </a:xfrm>
           <a:prstGeom prst="roundRect">
             <a:avLst>
-              <a:gd name="adj" fmla="val 2857"/>
+              <a:gd name="adj" fmla="val 2162"/>
             </a:avLst>
           </a:prstGeom>
           <a:solidFill>
@@ -17766,8 +17766,8 @@
         </p:nvSpPr>
         <p:spPr>
           <a:xfrm>
-            <a:off x="1097280" y="5029200"/>
-            <a:ext cx="1828800" cy="274320"/>
+            <a:off x="960120" y="4773168"/>
+            <a:ext cx="2286000" cy="320040"/>
           </a:xfrm>
           <a:prstGeom prst="rect">
             <a:avLst/>
@@ -17783,7 +17783,7 @@
               <a:buNone/>
             </a:pPr>
             <a:r>
-              <a:rPr lang="en-US" sz="900" b="1" dirty="0">
+              <a:rPr lang="en-US" sz="1100" b="1" dirty="0">
                 <a:solidFill>
                   <a:srgbClr val="C9A84C"/>
                 </a:solidFill>
@@ -17793,7 +17793,7 @@
               </a:rPr>
               <a:t>Market Context</a:t>
             </a:r>
-            <a:endParaRPr lang="en-US" sz="900" dirty="0"/>
+            <a:endParaRPr lang="en-US" sz="1100" dirty="0"/>
           </a:p>
         </p:txBody>
       </p:sp>
@@ -17805,8 +17805,8 @@
         </p:nvSpPr>
         <p:spPr>
           <a:xfrm>
-            <a:off x="1097280" y="5321808"/>
-            <a:ext cx="9966960" cy="777240"/>
+            <a:off x="960120" y="5120640"/>
+            <a:ext cx="10332720" cy="1097280"/>
           </a:xfrm>
           <a:prstGeom prst="rect">
             <a:avLst/>
@@ -17822,7 +17822,7 @@
               <a:buNone/>
             </a:pPr>
             <a:r>
-              <a:rPr lang="en-US" sz="950" dirty="0">
+              <a:rPr lang="en-US" sz="1150" dirty="0">
                 <a:solidFill>
                   <a:srgbClr val="AABDD0"/>
                 </a:solidFill>
@@ -17832,7 +17832,7 @@
               </a:rPr>
               <a:t>SOFR has stabilized in the 5.30–5.35% range, keeping floating-rate coupon income near cycle highs. Sunbelt multifamily fundamentals remain strong with vacancy rates below 5% in the fund's key markets. Industrial demand continues to benefit from e-commerce tailwinds and near-shoring activity.</a:t>
             </a:r>
-            <a:endParaRPr lang="en-US" sz="950" dirty="0"/>
+            <a:endParaRPr lang="en-US" sz="1150" dirty="0"/>
           </a:p>
         </p:txBody>
       </p:sp>
@@ -18070,7 +18070,7 @@
                 <a:gridCol w="6858000"/>
                 <a:gridCol w="4389120"/>
               </a:tblGrid>
-              <a:tr h="329184">
+              <a:tr h="384048">
                 <a:tc>
                   <a:txBody>
                     <a:bodyPr/>
@@ -18208,7 +18208,7 @@
                   </a:tcPr>
                 </a:tc>
               </a:tr>
-              <a:tr h="329184">
+              <a:tr h="384048">
                 <a:tc>
                   <a:txBody>
                     <a:bodyPr/>
@@ -18335,7 +18335,7 @@
                   </a:tcPr>
                 </a:tc>
               </a:tr>
-              <a:tr h="329184">
+              <a:tr h="384048">
                 <a:tc>
                   <a:txBody>
                     <a:bodyPr/>
@@ -18473,7 +18473,7 @@
                   </a:tcPr>
                 </a:tc>
               </a:tr>
-              <a:tr h="329184">
+              <a:tr h="384048">
                 <a:tc>
                   <a:txBody>
                     <a:bodyPr/>
@@ -18611,7 +18611,7 @@
                   </a:tcPr>
                 </a:tc>
               </a:tr>
-              <a:tr h="329184">
+              <a:tr h="384048">
                 <a:tc>
                   <a:txBody>
                     <a:bodyPr/>
@@ -18749,7 +18749,7 @@
                   </a:tcPr>
                 </a:tc>
               </a:tr>
-              <a:tr h="329184">
+              <a:tr h="384048">
                 <a:tc>
                   <a:txBody>
                     <a:bodyPr/>
@@ -18876,7 +18876,7 @@
                   </a:tcPr>
                 </a:tc>
               </a:tr>
-              <a:tr h="329184">
+              <a:tr h="384048">
                 <a:tc>
                   <a:txBody>
                     <a:bodyPr/>
@@ -19014,7 +19014,7 @@
                   </a:tcPr>
                 </a:tc>
               </a:tr>
-              <a:tr h="329184">
+              <a:tr h="384048">
                 <a:tc>
                   <a:txBody>
                     <a:bodyPr/>
@@ -19152,7 +19152,7 @@
                   </a:tcPr>
                 </a:tc>
               </a:tr>
-              <a:tr h="329184">
+              <a:tr h="384048">
                 <a:tc>
                   <a:txBody>
                     <a:bodyPr/>
@@ -19290,7 +19290,7 @@
                   </a:tcPr>
                 </a:tc>
               </a:tr>
-              <a:tr h="329184">
+              <a:tr h="384048">
                 <a:tc>
                   <a:txBody>
                     <a:bodyPr/>
@@ -19417,7 +19417,7 @@
                   </a:tcPr>
                 </a:tc>
               </a:tr>
-              <a:tr h="329184">
+              <a:tr h="384048">
                 <a:tc>
                   <a:txBody>
                     <a:bodyPr/>
@@ -19555,7 +19555,7 @@
                   </a:tcPr>
                 </a:tc>
               </a:tr>
-              <a:tr h="329184">
+              <a:tr h="384048">
                 <a:tc>
                   <a:txBody>
                     <a:bodyPr/>
@@ -19693,7 +19693,7 @@
                   </a:tcPr>
                 </a:tc>
               </a:tr>
-              <a:tr h="329184">
+              <a:tr h="384048">
                 <a:tc>
                   <a:txBody>
                     <a:bodyPr/>
@@ -19831,7 +19831,7 @@
                   </a:tcPr>
                 </a:tc>
               </a:tr>
-              <a:tr h="329184">
+              <a:tr h="384048">
                 <a:tc>
                   <a:txBody>
                     <a:bodyPr/>
@@ -19958,7 +19958,7 @@
                   </a:tcPr>
                 </a:tc>
               </a:tr>
-              <a:tr h="329184">
+              <a:tr h="384048">
                 <a:tc>
                   <a:txBody>
                     <a:bodyPr/>

</xml_diff>